<commit_message>
Clarify AI/WebRTC as UI mocks on chat slide and balance team roles for defense.
</commit_message>
<xml_diff>
--- a/docs/LinkedIn_Diploma_Presentation_UA.pptx
+++ b/docs/LinkedIn_Diploma_Presentation_UA.pptx
@@ -10142,7 +10142,7 @@
               </a:defRPr>
             </a:pPr>
             <a:r>
-              <a:t>Зона відповідальності: Головний екран і динамічна контентна стрічка (Feed).</a:t>
+              <a:t>Зона відповідальності: Home/Feed: AppContext, оптимізація рендерингу стрічки, динамічні реакції.</a:t>
             </a:r>
           </a:p>
         </p:txBody>
@@ -10265,7 +10265,7 @@
               </a:defRPr>
             </a:pPr>
             <a:r>
-              <a:t>Зона відповідальності: Архітектура Network: контакти, groups, pages, events.</a:t>
+              <a:t>Зона відповідальності: Network: контакти, groups, pages, events, EventPanel.</a:t>
             </a:r>
           </a:p>
         </p:txBody>
@@ -10388,7 +10388,7 @@
               </a:defRPr>
             </a:pPr>
             <a:r>
-              <a:t>Зона відповідальності: API-клієнт, інтеграція з backend і E2E verify (17/17).</a:t>
+              <a:t>Зона відповідальності: API-клієнт, backend-інтеграція та E2E verify (17/17).</a:t>
             </a:r>
           </a:p>
         </p:txBody>
@@ -15813,7 +15813,7 @@
               </a:defRPr>
             </a:pPr>
             <a:r>
-              <a:t>діалоги, unread, UI mock AI/WebRTC</a:t>
+              <a:t>SignalR live + AI/WebRTC UI mock</a:t>
             </a:r>
           </a:p>
         </p:txBody>
@@ -15848,7 +15848,7 @@
               </a:defRPr>
             </a:pPr>
             <a:r>
-              <a:t>Обґрунтування рішення: Чати додають платформі внутрішню комунікацію без переходу в сторонні месенджери.</a:t>
+              <a:t>Обґрунтування рішення: Чати — live messaging через SignalR; AI-асистент і дзвінки — UI-шар для наступних релізів.</a:t>
             </a:r>
           </a:p>
         </p:txBody>
@@ -16092,7 +16092,7 @@
               </a:defRPr>
             </a:pPr>
             <a:r>
-              <a:t>Обране рішення: SignalR hub для realtime повідомлень; unread, archive, mute, delete, share posts.</a:t>
+              <a:t>Обране рішення: SignalR hub для realtime повідомлень; unread, archive, mute, delete, share posts — live API.</a:t>
             </a:r>
           </a:p>
         </p:txBody>
@@ -16170,7 +16170,7 @@
               </a:defRPr>
             </a:pPr>
             <a:r>
-              <a:t>Реалізація: AI assistant session з quick prompts; VoiceCallOverlay — UI-демо дзвінків.</a:t>
+              <a:t>Реалізація: AI assistant і VoiceCallOverlay: повністю спроєктований UI-шар; на захисті — інтерактивні mock-моделі.</a:t>
             </a:r>
           </a:p>
         </p:txBody>
@@ -16248,7 +16248,7 @@
               </a:defRPr>
             </a:pPr>
             <a:r>
-              <a:t>Результат: Чати інтегровані з network: відкриття діалогу з картки контакту.</a:t>
+              <a:t>Результат: Live WebRTC інтеграція запланована на наступні релізи; core messaging уже працює з backend.</a:t>
             </a:r>
           </a:p>
         </p:txBody>
@@ -18743,7 +18743,7 @@
               </a:defRPr>
             </a:pPr>
             <a:r>
-              <a:t>стрічка, навігація, швидкий доступ</a:t>
+              <a:t>AppContext hub, routing, feed init</a:t>
             </a:r>
           </a:p>
         </p:txBody>
@@ -18778,7 +18778,7 @@
               </a:defRPr>
             </a:pPr>
             <a:r>
-              <a:t>Обґрунтування рішення: Головний екран задає перше враження і веде користувача до основних розділів платформи.</a:t>
+              <a:t>Обґрунтування рішення: Home — архітектурний hub після auth: зв'язує AppContext, routing і завантаження Feed.</a:t>
             </a:r>
           </a:p>
         </p:txBody>
@@ -18944,7 +18944,7 @@
               </a:defRPr>
             </a:pPr>
             <a:r>
-              <a:t>Причина вибору: Створено структуру home-сторінки з фокусом на професійний контент.</a:t>
+              <a:t>Причина вибору: Стартова точка після login: orchestration layout, sidebar, швидкий доступ до модулів.</a:t>
             </a:r>
           </a:p>
         </p:txBody>
@@ -19022,7 +19022,7 @@
               </a:defRPr>
             </a:pPr>
             <a:r>
-              <a:t>Обране рішення: Додано швидкий доступ до мережі, вакансій, повідомлень і профілю.</a:t>
+              <a:t>Обране рішення: AppContext передає account/profile у Home без prop drilling через legacy stores.</a:t>
             </a:r>
           </a:p>
         </p:txBody>
@@ -19100,7 +19100,7 @@
               </a:defRPr>
             </a:pPr>
             <a:r>
-              <a:t>Реалізація: Головний екран працює як стартова точка після авторизації.</a:t>
+              <a:t>Реалізація: Home ініціює завантаження стрічки з content API — перехід до найскладнішого модуля Feed.</a:t>
             </a:r>
           </a:p>
         </p:txBody>
@@ -19178,7 +19178,7 @@
               </a:defRPr>
             </a:pPr>
             <a:r>
-              <a:t>Результат: Навігація допомагає показати сайт як цілісну платформу.</a:t>
+              <a:t>Результат: Єдиний UX-hub: мережа, вакансії, повідомлення, профіль з одного екрана.</a:t>
             </a:r>
           </a:p>
         </p:txBody>
@@ -20208,7 +20208,7 @@
               </a:defRPr>
             </a:pPr>
             <a:r>
-              <a:t>пости, реакції, коментарі, providers</a:t>
+              <a:t>state, render opt., reactions</a:t>
             </a:r>
           </a:p>
         </p:txBody>
@@ -20243,7 +20243,7 @@
               </a:defRPr>
             </a:pPr>
             <a:r>
-              <a:t>Обґрунтування рішення: Feed — найскладніша frontend-частина: динамічні пости, реакції та оновлення стану.</a:t>
+              <a:t>Обґрунтування рішення: Feed — найскладніший архітектурний модуль: глобальний стан, рендеринг і динамічні реакції.</a:t>
             </a:r>
           </a:p>
         </p:txBody>
@@ -20409,7 +20409,7 @@
               </a:defRPr>
             </a:pPr>
             <a:r>
-              <a:t>Причина вибору: Пости завантажуються з content API; enrichPostsWithAuthors для імен і аватарів.</a:t>
+              <a:t>Причина вибору: AppContext + локальний state: пости з content API, enrichPostsWithAuthors без full reload.</a:t>
             </a:r>
           </a:p>
         </p:txBody>
@@ -20487,7 +20487,7 @@
               </a:defRPr>
             </a:pPr>
             <a:r>
-              <a:t>Обране рішення: Реакції, коментарі, share menu, PostViewRecorder — повний engagement flow.</a:t>
+              <a:t>Обране рішення: Оптимізація рендерингу: PostCard, reactions, comments оновлюються точково після дії користувача.</a:t>
             </a:r>
           </a:p>
         </p:txBody>
@@ -20565,7 +20565,7 @@
               </a:defRPr>
             </a:pPr>
             <a:r>
-              <a:t>Реалізація: CreatePost modal з rich text і media; hashtags following panel.</a:t>
+              <a:t>Реалізація: PostEngagement, PostCommentsPanel, PostShareMenu — повний цикл взаємодії з backend.</a:t>
             </a:r>
           </a:p>
         </p:txBody>
@@ -20643,7 +20643,7 @@
               </a:defRPr>
             </a:pPr>
             <a:r>
-              <a:t>Результат: Стрічка оновлюється без reload через API + локальний state.</a:t>
+              <a:t>Результат: CreatePost modal, rich text, media — технічно складніший блок, ніж статичні auth/profile форми.</a:t>
             </a:r>
           </a:p>
         </p:txBody>

</xml_diff>